<commit_message>
fix(presentation): fix layout bounds, enlarge typography, remove personal footer names
</commit_message>
<xml_diff>
--- a/output/HPC_Locality_Scheduling_Presentation.pptx
+++ b/output/HPC_Locality_Scheduling_Presentation.pptx
@@ -15,8 +15,8 @@
   <p:notesMasterIdLst>
     <p:notesMasterId r:id="rId8"/>
   </p:notesMasterIdLst>
-  <p:sldSz cx="9144000" cy="5143500"/>
-  <p:notesSz cx="5143500" cy="9144000"/>
+  <p:sldSz cx="12191695" cy="6858000"/>
+  <p:notesSz cx="6858000" cy="12191695"/>
   <p:defaultTextStyle>
     <a:lvl1pPr marL="0" algn="l" defTabSz="914400" rtl="0" eaLnBrk="1" latinLnBrk="0" hangingPunct="1">
       <a:defRPr sz="1800" kern="1200">
@@ -1876,7 +1876,7 @@
                 <a:ea typeface="Courier New" pitchFamily="34" charset="-122"/>
                 <a:cs typeface="Courier New" pitchFamily="34" charset="-120"/>
               </a:rPr>
-              <a:t>Qasim · Awadesh · Devashish · Husaam · Chirag</a:t>
+              <a:t>Locality-Aware Task Scheduling on Heterogeneous HPC Architectures</a:t>
             </a:r>
             <a:endParaRPr lang="en-US" sz="950" dirty="0"/>
           </a:p>
@@ -8784,7 +8784,7 @@
                 <a:ea typeface="Courier New" pitchFamily="34" charset="-122"/>
                 <a:cs typeface="Courier New" pitchFamily="34" charset="-120"/>
               </a:rPr>
-              <a:t>Final HPC Project Defense · Qasim · Awadesh · Devashish · Husaam · Chirag</a:t>
+              <a:t>Locality-Aware Task Scheduling · Final Project Defense</a:t>
             </a:r>
             <a:endParaRPr lang="en-US" sz="950" dirty="0"/>
           </a:p>

</xml_diff>